<commit_message>
Fix merged template: restore branding and widen placeholders
Manual PowerPoint adjustments to the merged template:
- Added CONFIDENTIAL text box (top-right)
- Added Ci logo (bottom-left)
- Widened title/body placeholders to 12.59" (was 11.49")
- Removed bullet levels 4-5 (not recommended for presentations)

Co-Authored-By: Claude Opus 4.5 <noreply@anthropic.com>
</commit_message>
<xml_diff>
--- a/.claude/skills/presentation/templates/cellularintelligence.pptx
+++ b/.claude/skills/presentation/templates/cellularintelligence.pptx
@@ -5,10 +5,10 @@
     <p:sldMasterId id="2147483648" r:id="rId4"/>
   </p:sldMasterIdLst>
   <p:notesMasterIdLst>
-    <p:notesMasterId r:id="rId18"/>
+    <p:notesMasterId r:id="rId6"/>
   </p:notesMasterIdLst>
   <p:sldIdLst>
-    <p:sldId id="256" r:id="rId12"/>
+    <p:sldId id="256" r:id="rId5"/>
   </p:sldIdLst>
   <p:sldSz cx="12192000" cy="6858000"/>
   <p:notesSz cx="6858000" cy="9144000"/>
@@ -589,7 +589,7 @@
             <a:spLocks noGrp="1"/>
           </p:cNvSpPr>
           <p:nvPr>
-            <p:ph type="body" sz="quarter" idx="1"/>
+            <p:ph type="body" sz="quarter" idx="1" hasCustomPrompt="1"/>
           </p:nvPr>
         </p:nvSpPr>
         <p:spPr>
@@ -620,7 +620,7 @@
               <a:buClrTx/>
               <a:buSzTx/>
               <a:buNone/>
-              <a:defRPr sz="2700"/>
+              <a:defRPr sz="2400"/>
             </a:lvl2pPr>
             <a:lvl3pPr marL="0" indent="0" algn="ctr">
               <a:spcBef>
@@ -652,31 +652,15 @@
           </a:lstStyle>
           <a:p>
             <a:r>
+              <a:rPr dirty="0"/>
               <a:t>Body Level One</a:t>
             </a:r>
           </a:p>
           <a:p>
             <a:pPr lvl="1"/>
             <a:r>
+              <a:rPr dirty="0"/>
               <a:t>Body Level Two</a:t>
-            </a:r>
-          </a:p>
-          <a:p>
-            <a:pPr lvl="2"/>
-            <a:r>
-              <a:t>Body Level Three</a:t>
-            </a:r>
-          </a:p>
-          <a:p>
-            <a:pPr lvl="3"/>
-            <a:r>
-              <a:t>Body Level Four</a:t>
-            </a:r>
-          </a:p>
-          <a:p>
-            <a:pPr lvl="4"/>
-            <a:r>
-              <a:t>Body Level Five</a:t>
             </a:r>
           </a:p>
         </p:txBody>
@@ -1162,7 +1146,7 @@
             <a:fld id="{FB2935F8-297A-F844-8555-D6E4631F7E59}" type="datetimeFigureOut">
               <a:rPr lang="en-US" smtClean="0"/>
               <a:pPr/>
-              <a:t>1/29/26</a:t>
+              <a:t>1/30/26</a:t>
             </a:fld>
             <a:endParaRPr lang="en-US"/>
           </a:p>
@@ -1965,7 +1949,7 @@
             <a:fld id="{FB2935F8-297A-F844-8555-D6E4631F7E59}" type="datetimeFigureOut">
               <a:rPr lang="en-US" smtClean="0"/>
               <a:pPr/>
-              <a:t>1/29/26</a:t>
+              <a:t>1/30/26</a:t>
             </a:fld>
             <a:endParaRPr lang="en-US"/>
           </a:p>
@@ -2597,31 +2581,22 @@
           </a:lstStyle>
           <a:p>
             <a:r>
+              <a:rPr dirty="0"/>
               <a:t>Body Level One</a:t>
             </a:r>
           </a:p>
           <a:p>
             <a:pPr lvl="1"/>
             <a:r>
+              <a:rPr dirty="0"/>
               <a:t>Body Level Two</a:t>
             </a:r>
           </a:p>
           <a:p>
             <a:pPr lvl="2"/>
             <a:r>
+              <a:rPr dirty="0"/>
               <a:t>Body Level Three</a:t>
-            </a:r>
-          </a:p>
-          <a:p>
-            <a:pPr lvl="3"/>
-            <a:r>
-              <a:t>Body Level Four</a:t>
-            </a:r>
-          </a:p>
-          <a:p>
-            <a:pPr lvl="4"/>
-            <a:r>
-              <a:t>Body Level Five</a:t>
             </a:r>
           </a:p>
         </p:txBody>
@@ -2853,31 +2828,22 @@
           </a:lstStyle>
           <a:p>
             <a:r>
+              <a:rPr dirty="0"/>
               <a:t>Body Level One</a:t>
             </a:r>
           </a:p>
           <a:p>
             <a:pPr lvl="1"/>
             <a:r>
+              <a:rPr dirty="0"/>
               <a:t>Body Level Two</a:t>
             </a:r>
           </a:p>
           <a:p>
             <a:pPr lvl="2"/>
             <a:r>
+              <a:rPr dirty="0"/>
               <a:t>Body Level Three</a:t>
-            </a:r>
-          </a:p>
-          <a:p>
-            <a:pPr lvl="3"/>
-            <a:r>
-              <a:t>Body Level Four</a:t>
-            </a:r>
-          </a:p>
-          <a:p>
-            <a:pPr lvl="4"/>
-            <a:r>
-              <a:t>Body Level Five</a:t>
             </a:r>
           </a:p>
         </p:txBody>
@@ -3000,7 +2966,7 @@
             <a:spLocks noGrp="1"/>
           </p:cNvSpPr>
           <p:nvPr>
-            <p:ph type="body" sz="half" idx="1"/>
+            <p:ph type="body" sz="half" idx="1" hasCustomPrompt="1"/>
           </p:nvPr>
         </p:nvSpPr>
         <p:spPr>
@@ -3053,31 +3019,22 @@
           </a:lstStyle>
           <a:p>
             <a:r>
+              <a:rPr dirty="0"/>
               <a:t>Body Level One</a:t>
             </a:r>
           </a:p>
           <a:p>
             <a:pPr lvl="1"/>
             <a:r>
+              <a:rPr dirty="0"/>
               <a:t>Body Level Two</a:t>
             </a:r>
           </a:p>
           <a:p>
             <a:pPr lvl="2"/>
             <a:r>
+              <a:rPr dirty="0"/>
               <a:t>Body Level Three</a:t>
-            </a:r>
-          </a:p>
-          <a:p>
-            <a:pPr lvl="3"/>
-            <a:r>
-              <a:t>Body Level Four</a:t>
-            </a:r>
-          </a:p>
-          <a:p>
-            <a:pPr lvl="4"/>
-            <a:r>
-              <a:t>Body Level Five</a:t>
             </a:r>
           </a:p>
         </p:txBody>
@@ -3782,7 +3739,7 @@
             <a:fld id="{FB2935F8-297A-F844-8555-D6E4631F7E59}" type="datetimeFigureOut">
               <a:rPr lang="en-US" smtClean="0"/>
               <a:pPr/>
-              <a:t>1/29/26</a:t>
+              <a:t>1/30/26</a:t>
             </a:fld>
             <a:endParaRPr lang="en-US"/>
           </a:p>
@@ -4592,7 +4549,7 @@
             <a:fld id="{FB2935F8-297A-F844-8555-D6E4631F7E59}" type="datetimeFigureOut">
               <a:rPr lang="en-US" smtClean="0"/>
               <a:pPr/>
-              <a:t>1/29/26</a:t>
+              <a:t>1/30/26</a:t>
             </a:fld>
             <a:endParaRPr lang="en-US"/>
           </a:p>
@@ -5068,7 +5025,7 @@
         <p:spPr>
           <a:xfrm>
             <a:off x="386899" y="386899"/>
-            <a:ext cx="10502900" cy="603701"/>
+            <a:ext cx="11512296" cy="603701"/>
           </a:xfrm>
           <a:prstGeom prst="rect">
             <a:avLst/>
@@ -5078,7 +5035,7 @@
           </a:ln>
           <a:extLst>
             <a:ext uri="{C572A759-6A51-4108-AA02-DFA0A04FC94B}">
-              <ma14:wrappingTextBoxFlag xmlns="" xmlns:ma14="http://schemas.microsoft.com/office/mac/drawingml/2011/main" xmlns:a14="http://schemas.microsoft.com/office/drawing/2010/main" xmlns:m="http://schemas.openxmlformats.org/officeDocument/2006/math" val="1"/>
+              <ma14:wrappingTextBoxFlag xmlns:m="http://schemas.openxmlformats.org/officeDocument/2006/math" xmlns:a14="http://schemas.microsoft.com/office/drawing/2010/main" xmlns:ma14="http://schemas.microsoft.com/office/mac/drawingml/2011/main" xmlns="" val="1"/>
             </a:ext>
           </a:extLst>
         </p:spPr>
@@ -5107,7 +5064,7 @@
         <p:spPr>
           <a:xfrm>
             <a:off x="387391" y="1510234"/>
-            <a:ext cx="10502900" cy="4648200"/>
+            <a:ext cx="11512296" cy="4648200"/>
           </a:xfrm>
           <a:prstGeom prst="rect">
             <a:avLst/>
@@ -5117,7 +5074,7 @@
           </a:ln>
           <a:extLst>
             <a:ext uri="{C572A759-6A51-4108-AA02-DFA0A04FC94B}">
-              <ma14:wrappingTextBoxFlag xmlns="" xmlns:ma14="http://schemas.microsoft.com/office/mac/drawingml/2011/main" xmlns:a14="http://schemas.microsoft.com/office/drawing/2010/main" xmlns:m="http://schemas.openxmlformats.org/officeDocument/2006/math" val="1"/>
+              <ma14:wrappingTextBoxFlag xmlns:m="http://schemas.openxmlformats.org/officeDocument/2006/math" xmlns:a14="http://schemas.microsoft.com/office/drawing/2010/main" xmlns:ma14="http://schemas.microsoft.com/office/mac/drawingml/2011/main" xmlns="" val="1"/>
             </a:ext>
           </a:extLst>
         </p:spPr>
@@ -5128,31 +5085,22 @@
           <a:lstStyle/>
           <a:p>
             <a:r>
+              <a:rPr dirty="0"/>
               <a:t>Body Level One</a:t>
             </a:r>
           </a:p>
           <a:p>
             <a:pPr lvl="1"/>
             <a:r>
+              <a:rPr dirty="0"/>
               <a:t>Body Level Two</a:t>
             </a:r>
           </a:p>
           <a:p>
             <a:pPr lvl="2"/>
             <a:r>
+              <a:rPr dirty="0"/>
               <a:t>Body Level Three</a:t>
-            </a:r>
-          </a:p>
-          <a:p>
-            <a:pPr lvl="3"/>
-            <a:r>
-              <a:t>Body Level Four</a:t>
-            </a:r>
-          </a:p>
-          <a:p>
-            <a:pPr lvl="4"/>
-            <a:r>
-              <a:t>Body Level Five</a:t>
             </a:r>
           </a:p>
         </p:txBody>
@@ -5204,6 +5152,119 @@
           </a:p>
         </p:txBody>
       </p:sp>
+      <p:pic>
+        <p:nvPicPr>
+          <p:cNvPr id="5" name="Picture 4">
+            <a:extLst>
+              <a:ext uri="{FF2B5EF4-FFF2-40B4-BE49-F238E27FC236}">
+                <a16:creationId xmlns:a16="http://schemas.microsoft.com/office/drawing/2014/main" id="{E0DEBFD5-D320-7EDD-0B4A-A06E38C2C749}"/>
+              </a:ext>
+            </a:extLst>
+          </p:cNvPr>
+          <p:cNvPicPr>
+            <a:picLocks noChangeAspect="1"/>
+          </p:cNvPicPr>
+          <p:nvPr userDrawn="1"/>
+        </p:nvPicPr>
+        <p:blipFill>
+          <a:blip r:embed="rId13"/>
+          <a:srcRect l="4356" t="11145" r="84944" b="51846"/>
+          <a:stretch>
+            <a:fillRect/>
+          </a:stretch>
+        </p:blipFill>
+        <p:spPr>
+          <a:xfrm>
+            <a:off x="0" y="6540500"/>
+            <a:ext cx="422275" cy="289375"/>
+          </a:xfrm>
+          <a:prstGeom prst="rect">
+            <a:avLst/>
+          </a:prstGeom>
+        </p:spPr>
+      </p:pic>
+      <p:sp>
+        <p:nvSpPr>
+          <p:cNvPr id="6" name="TextBox 5">
+            <a:extLst>
+              <a:ext uri="{FF2B5EF4-FFF2-40B4-BE49-F238E27FC236}">
+                <a16:creationId xmlns:a16="http://schemas.microsoft.com/office/drawing/2014/main" id="{58D56D1E-9A96-8A76-600E-5585649ABD52}"/>
+              </a:ext>
+            </a:extLst>
+          </p:cNvPr>
+          <p:cNvSpPr txBox="1"/>
+          <p:nvPr userDrawn="1"/>
+        </p:nvSpPr>
+        <p:spPr>
+          <a:xfrm>
+            <a:off x="11150048" y="0"/>
+            <a:ext cx="1041952" cy="256480"/>
+          </a:xfrm>
+          <a:prstGeom prst="rect">
+            <a:avLst/>
+          </a:prstGeom>
+          <a:noFill/>
+          <a:ln w="12700" cap="flat">
+            <a:noFill/>
+            <a:miter lim="400000"/>
+          </a:ln>
+          <a:effectLst/>
+          <a:sp3d/>
+        </p:spPr>
+        <p:style>
+          <a:lnRef idx="0">
+            <a:scrgbClr r="0" g="0" b="0"/>
+          </a:lnRef>
+          <a:fillRef idx="0">
+            <a:scrgbClr r="0" g="0" b="0"/>
+          </a:fillRef>
+          <a:effectRef idx="0">
+            <a:scrgbClr r="0" g="0" b="0"/>
+          </a:effectRef>
+          <a:fontRef idx="none"/>
+        </p:style>
+        <p:txBody>
+          <a:bodyPr rot="0" spcFirstLastPara="1" vertOverflow="overflow" horzOverflow="overflow" vert="horz" wrap="none" lIns="50800" tIns="50800" rIns="50800" bIns="50800" numCol="1" spcCol="38100" rtlCol="0" anchor="ctr">
+            <a:spAutoFit/>
+          </a:bodyPr>
+          <a:lstStyle/>
+          <a:p>
+            <a:pPr marL="0" marR="0" indent="0" algn="l" defTabSz="825500" rtl="0" fontAlgn="auto" latinLnBrk="0" hangingPunct="0">
+              <a:lnSpc>
+                <a:spcPct val="100000"/>
+              </a:lnSpc>
+              <a:spcBef>
+                <a:spcPts val="0"/>
+              </a:spcBef>
+              <a:spcAft>
+                <a:spcPts val="0"/>
+              </a:spcAft>
+              <a:buClrTx/>
+              <a:buSzTx/>
+              <a:buFontTx/>
+              <a:buNone/>
+              <a:tabLst/>
+            </a:pPr>
+            <a:r>
+              <a:rPr kumimoji="0" lang="en-US" sz="1000" b="0" i="1" u="none" strike="noStrike" cap="none" spc="0" normalizeH="0" baseline="0" dirty="0">
+                <a:ln>
+                  <a:noFill/>
+                </a:ln>
+                <a:solidFill>
+                  <a:srgbClr val="FFFFFF"/>
+                </a:solidFill>
+                <a:effectLst/>
+                <a:uFillTx/>
+                <a:latin typeface="Helvetica Neue"/>
+                <a:ea typeface="Helvetica Neue"/>
+                <a:cs typeface="Helvetica Neue"/>
+                <a:sym typeface="Helvetica Neue"/>
+              </a:rPr>
+              <a:t>CONFIDENTIAL</a:t>
+            </a:r>
+          </a:p>
+        </p:txBody>
+      </p:sp>
     </p:spTree>
   </p:cSld>
   <p:clrMap bg1="dk1" tx1="lt1" bg2="dk2" tx2="lt2" accent1="accent1" accent2="accent2" accent3="accent3" accent4="accent4" accent5="accent5" accent6="accent6" hlink="hlink" folHlink="folHlink"/>
@@ -5214,11 +5275,11 @@
     <p:sldLayoutId id="2147483664" r:id="rId4"/>
     <p:sldLayoutId id="2147483655" r:id="rId5"/>
     <p:sldLayoutId id="2147483662" r:id="rId6"/>
-    <p:sldLayoutId id="2147483665" r:id="rId8"/>
-    <p:sldLayoutId id="2147483666" r:id="rId9"/>
-    <p:sldLayoutId id="2147483667" r:id="rId10"/>
-    <p:sldLayoutId id="2147483668" r:id="rId11"/>
-    <p:sldLayoutId id="2147483669" r:id="rId12"/>
+    <p:sldLayoutId id="2147483665" r:id="rId7"/>
+    <p:sldLayoutId id="2147483666" r:id="rId8"/>
+    <p:sldLayoutId id="2147483667" r:id="rId9"/>
+    <p:sldLayoutId id="2147483668" r:id="rId10"/>
+    <p:sldLayoutId id="2147483669" r:id="rId11"/>
   </p:sldLayoutIdLst>
   <p:transition spd="med"/>
   <p:txStyles>
@@ -5464,7 +5525,7 @@
           <a:spcPct val="100000"/>
         </a:lnSpc>
         <a:spcBef>
-          <a:spcPts val="2950"/>
+          <a:spcPts val="1200"/>
         </a:spcBef>
         <a:spcAft>
           <a:spcPts val="0"/>
@@ -5492,7 +5553,7 @@
           <a:spcPct val="100000"/>
         </a:lnSpc>
         <a:spcBef>
-          <a:spcPts val="2950"/>
+          <a:spcPts val="1200"/>
         </a:spcBef>
         <a:spcAft>
           <a:spcPts val="0"/>
@@ -5520,7 +5581,7 @@
           <a:spcPct val="100000"/>
         </a:lnSpc>
         <a:spcBef>
-          <a:spcPts val="2950"/>
+          <a:spcPts val="1200"/>
         </a:spcBef>
         <a:spcAft>
           <a:spcPts val="0"/>
@@ -5548,7 +5609,7 @@
           <a:spcPct val="100000"/>
         </a:lnSpc>
         <a:spcBef>
-          <a:spcPts val="2950"/>
+          <a:spcPts val="1200"/>
         </a:spcBef>
         <a:spcAft>
           <a:spcPts val="0"/>
@@ -5576,7 +5637,7 @@
           <a:spcPct val="100000"/>
         </a:lnSpc>
         <a:spcBef>
-          <a:spcPts val="2950"/>
+          <a:spcPts val="1200"/>
         </a:spcBef>
         <a:spcAft>
           <a:spcPts val="0"/>
@@ -5979,7 +6040,7 @@
 </file>
 
 <file path=ppt/slides/slide1.xml><?xml version="1.0" encoding="utf-8"?>
-<p:sld xmlns:a="http://schemas.openxmlformats.org/drawingml/2006/main" xmlns:p="http://schemas.openxmlformats.org/presentationml/2006/main" xmlns:r="http://schemas.openxmlformats.org/officeDocument/2006/relationships">
+<p:sld xmlns:a="http://schemas.openxmlformats.org/drawingml/2006/main" xmlns:r="http://schemas.openxmlformats.org/officeDocument/2006/relationships" xmlns:p="http://schemas.openxmlformats.org/presentationml/2006/main">
   <p:cSld>
     <p:spTree>
       <p:nvGrpSpPr>
@@ -5987,7 +6048,14 @@
         <p:cNvGrpSpPr/>
         <p:nvPr/>
       </p:nvGrpSpPr>
-      <p:grpSpPr/>
+      <p:grpSpPr>
+        <a:xfrm>
+          <a:off x="0" y="0"/>
+          <a:ext cx="0" cy="0"/>
+          <a:chOff x="0" y="0"/>
+          <a:chExt cx="0" cy="0"/>
+        </a:xfrm>
+      </p:grpSpPr>
       <p:sp>
         <p:nvSpPr>
           <p:cNvPr id="2" name="Title 1"/>
@@ -6016,7 +6084,7 @@
             <a:spLocks noGrp="1"/>
           </p:cNvSpPr>
           <p:nvPr>
-            <p:ph type="body" idx="1" sz="quarter"/>
+            <p:ph type="body" sz="quarter" idx="1"/>
           </p:nvPr>
         </p:nvSpPr>
         <p:spPr/>
@@ -8183,12 +8251,14 @@
 </file>
 
 <file path=customXml/item1.xml><?xml version="1.0" encoding="utf-8"?>
-<?mso-contentType ?>
-<FormTemplates xmlns="http://schemas.microsoft.com/sharepoint/v3/contenttype/forms">
-  <Display>DocumentLibraryForm</Display>
-  <Edit>DocumentLibraryForm</Edit>
-  <New>DocumentLibraryForm</New>
-</FormTemplates>
+<p:properties xmlns:p="http://schemas.microsoft.com/office/2006/metadata/properties" xmlns:xsi="http://www.w3.org/2001/XMLSchema-instance" xmlns:pc="http://schemas.microsoft.com/office/infopath/2007/PartnerControls">
+  <documentManagement>
+    <lcf76f155ced4ddcb4097134ff3c332f xmlns="baa02956-e5b0-401a-adb6-d3ab856a8db1">
+      <Terms xmlns="http://schemas.microsoft.com/office/infopath/2007/PartnerControls"/>
+    </lcf76f155ced4ddcb4097134ff3c332f>
+    <TaxCatchAll xmlns="758526ea-ff42-49f4-966e-8b92dfb8c37c" xsi:nil="true"/>
+  </documentManagement>
+</p:properties>
 </file>
 
 <file path=customXml/item2.xml><?xml version="1.0" encoding="utf-8"?>
@@ -8399,20 +8469,27 @@
 </file>
 
 <file path=customXml/item3.xml><?xml version="1.0" encoding="utf-8"?>
-<p:properties xmlns:p="http://schemas.microsoft.com/office/2006/metadata/properties" xmlns:xsi="http://www.w3.org/2001/XMLSchema-instance" xmlns:pc="http://schemas.microsoft.com/office/infopath/2007/PartnerControls">
-  <documentManagement>
-    <lcf76f155ced4ddcb4097134ff3c332f xmlns="baa02956-e5b0-401a-adb6-d3ab856a8db1">
-      <Terms xmlns="http://schemas.microsoft.com/office/infopath/2007/PartnerControls"/>
-    </lcf76f155ced4ddcb4097134ff3c332f>
-    <TaxCatchAll xmlns="758526ea-ff42-49f4-966e-8b92dfb8c37c" xsi:nil="true"/>
-  </documentManagement>
-</p:properties>
+<?mso-contentType ?>
+<FormTemplates xmlns="http://schemas.microsoft.com/sharepoint/v3/contenttype/forms">
+  <Display>DocumentLibraryForm</Display>
+  <Edit>DocumentLibraryForm</Edit>
+  <New>DocumentLibraryForm</New>
+</FormTemplates>
 </file>
 
 <file path=customXml/itemProps1.xml><?xml version="1.0" encoding="utf-8"?>
-<ds:datastoreItem xmlns:ds="http://schemas.openxmlformats.org/officeDocument/2006/customXml" ds:itemID="{F04B941D-E84F-47C8-84C7-8C66135B4CA1}">
+<ds:datastoreItem xmlns:ds="http://schemas.openxmlformats.org/officeDocument/2006/customXml" ds:itemID="{B517E194-3F2D-4BC4-9EAF-A0569BAF4335}">
   <ds:schemaRefs>
-    <ds:schemaRef ds:uri="http://schemas.microsoft.com/sharepoint/v3/contenttype/forms"/>
+    <ds:schemaRef ds:uri="http://purl.org/dc/dcmitype/"/>
+    <ds:schemaRef ds:uri="758526ea-ff42-49f4-966e-8b92dfb8c37c"/>
+    <ds:schemaRef ds:uri="http://www.w3.org/XML/1998/namespace"/>
+    <ds:schemaRef ds:uri="http://schemas.microsoft.com/office/2006/documentManagement/types"/>
+    <ds:schemaRef ds:uri="http://schemas.microsoft.com/office/infopath/2007/PartnerControls"/>
+    <ds:schemaRef ds:uri="http://purl.org/dc/elements/1.1/"/>
+    <ds:schemaRef ds:uri="baa02956-e5b0-401a-adb6-d3ab856a8db1"/>
+    <ds:schemaRef ds:uri="http://schemas.openxmlformats.org/package/2006/metadata/core-properties"/>
+    <ds:schemaRef ds:uri="http://schemas.microsoft.com/office/2006/metadata/properties"/>
+    <ds:schemaRef ds:uri="http://purl.org/dc/terms/"/>
   </ds:schemaRefs>
 </ds:datastoreItem>
 </file>
@@ -8437,18 +8514,9 @@
 </file>
 
 <file path=customXml/itemProps3.xml><?xml version="1.0" encoding="utf-8"?>
-<ds:datastoreItem xmlns:ds="http://schemas.openxmlformats.org/officeDocument/2006/customXml" ds:itemID="{B517E194-3F2D-4BC4-9EAF-A0569BAF4335}">
+<ds:datastoreItem xmlns:ds="http://schemas.openxmlformats.org/officeDocument/2006/customXml" ds:itemID="{F04B941D-E84F-47C8-84C7-8C66135B4CA1}">
   <ds:schemaRefs>
-    <ds:schemaRef ds:uri="http://purl.org/dc/dcmitype/"/>
-    <ds:schemaRef ds:uri="758526ea-ff42-49f4-966e-8b92dfb8c37c"/>
-    <ds:schemaRef ds:uri="http://www.w3.org/XML/1998/namespace"/>
-    <ds:schemaRef ds:uri="http://schemas.microsoft.com/office/2006/documentManagement/types"/>
-    <ds:schemaRef ds:uri="http://schemas.microsoft.com/office/infopath/2007/PartnerControls"/>
-    <ds:schemaRef ds:uri="http://purl.org/dc/elements/1.1/"/>
-    <ds:schemaRef ds:uri="baa02956-e5b0-401a-adb6-d3ab856a8db1"/>
-    <ds:schemaRef ds:uri="http://schemas.openxmlformats.org/package/2006/metadata/core-properties"/>
-    <ds:schemaRef ds:uri="http://schemas.microsoft.com/office/2006/metadata/properties"/>
-    <ds:schemaRef ds:uri="http://purl.org/dc/terms/"/>
+    <ds:schemaRef ds:uri="http://schemas.microsoft.com/sharepoint/v3/contenttype/forms"/>
   </ds:schemaRefs>
 </ds:datastoreItem>
 </file>
</xml_diff>

<commit_message>
Add example slides from official template
Template now includes 7 example slides demonstrating layout usage:
1. Blank - Mission statement
2. Title - Top alignment
3. Title - Center alignment
4. Title & Bullets
5. Title, Bullets & Photo
6. THANK YOU slide
7. Appendix slide

Co-Authored-By: Claude Opus 4.5 <noreply@anthropic.com>
</commit_message>
<xml_diff>
--- a/.claude/skills/presentation/templates/cellularintelligence.pptx
+++ b/.claude/skills/presentation/templates/cellularintelligence.pptx
@@ -9,6 +9,12 @@
   </p:notesMasterIdLst>
   <p:sldIdLst>
     <p:sldId id="256" r:id="rId5"/>
+    <p:sldId id="257" r:id="rId13"/>
+    <p:sldId id="258" r:id="rId14"/>
+    <p:sldId id="259" r:id="rId15"/>
+    <p:sldId id="260" r:id="rId16"/>
+    <p:sldId id="261" r:id="rId17"/>
+    <p:sldId id="262" r:id="rId18"/>
   </p:sldIdLst>
   <p:sldSz cx="12192000" cy="6858000"/>
   <p:notesSz cx="6858000" cy="9144000"/>
@@ -6040,7 +6046,7 @@
 </file>
 
 <file path=ppt/slides/slide1.xml><?xml version="1.0" encoding="utf-8"?>
-<p:sld xmlns:a="http://schemas.openxmlformats.org/drawingml/2006/main" xmlns:r="http://schemas.openxmlformats.org/officeDocument/2006/relationships" xmlns:p="http://schemas.openxmlformats.org/presentationml/2006/main">
+<p:sld xmlns:a="http://schemas.openxmlformats.org/drawingml/2006/main" xmlns:p="http://schemas.openxmlformats.org/presentationml/2006/main" xmlns:r="http://schemas.openxmlformats.org/officeDocument/2006/relationships">
   <p:cSld>
     <p:spTree>
       <p:nvGrpSpPr>
@@ -6048,14 +6054,56 @@
         <p:cNvGrpSpPr/>
         <p:nvPr/>
       </p:nvGrpSpPr>
-      <p:grpSpPr>
-        <a:xfrm>
-          <a:off x="0" y="0"/>
-          <a:ext cx="0" cy="0"/>
-          <a:chOff x="0" y="0"/>
-          <a:chExt cx="0" cy="0"/>
-        </a:xfrm>
-      </p:grpSpPr>
+      <p:grpSpPr/>
+      <p:sp>
+        <p:nvSpPr>
+          <p:cNvPr id="2" name="TextBox 1"/>
+          <p:cNvSpPr txBox="1"/>
+          <p:nvPr/>
+        </p:nvSpPr>
+        <p:spPr>
+          <a:xfrm>
+            <a:off x="1968975" y="3465085"/>
+            <a:ext cx="10111154" cy="1455754"/>
+          </a:xfrm>
+          <a:prstGeom prst="rect">
+            <a:avLst/>
+          </a:prstGeom>
+          <a:noFill/>
+        </p:spPr>
+        <p:txBody>
+          <a:bodyPr wrap="none">
+            <a:spAutoFit/>
+          </a:bodyPr>
+          <a:lstStyle/>
+          <a:p>
+            <a:r>
+              <a:rPr sz="2650">
+                <a:latin typeface="Helvetica"/>
+              </a:rPr>
+              <a:t>We are building a future where biology is no longer destiny, but design.</a:t>
+            </a:r>
+          </a:p>
+        </p:txBody>
+      </p:sp>
+    </p:spTree>
+  </p:cSld>
+  <p:clrMapOvr>
+    <a:masterClrMapping/>
+  </p:clrMapOvr>
+</p:sld>
+</file>
+
+<file path=ppt/slides/slide2.xml><?xml version="1.0" encoding="utf-8"?>
+<p:sld xmlns:a="http://schemas.openxmlformats.org/drawingml/2006/main" xmlns:p="http://schemas.openxmlformats.org/presentationml/2006/main" xmlns:r="http://schemas.openxmlformats.org/officeDocument/2006/relationships">
+  <p:cSld>
+    <p:spTree>
+      <p:nvGrpSpPr>
+        <p:cNvPr id="1" name=""/>
+        <p:cNvGrpSpPr/>
+        <p:nvPr/>
+      </p:nvGrpSpPr>
+      <p:grpSpPr/>
       <p:sp>
         <p:nvSpPr>
           <p:cNvPr id="2" name="Title 1"/>
@@ -6071,8 +6119,9 @@
           <a:bodyPr/>
           <a:lstStyle/>
           <a:p>
+            <a:pPr/>
             <a:r>
-              <a:t>Title</a:t>
+              <a:t>Example Title Slide - Top</a:t>
             </a:r>
           </a:p>
         </p:txBody>
@@ -6084,7 +6133,7 @@
             <a:spLocks noGrp="1"/>
           </p:cNvSpPr>
           <p:nvPr>
-            <p:ph type="body" sz="quarter" idx="1"/>
+            <p:ph type="body" idx="1" sz="quarter"/>
           </p:nvPr>
         </p:nvSpPr>
         <p:spPr/>
@@ -6092,8 +6141,340 @@
           <a:bodyPr/>
           <a:lstStyle/>
           <a:p>
+            <a:pPr/>
+          </a:p>
+        </p:txBody>
+      </p:sp>
+    </p:spTree>
+  </p:cSld>
+  <p:clrMapOvr>
+    <a:masterClrMapping/>
+  </p:clrMapOvr>
+</p:sld>
+</file>
+
+<file path=ppt/slides/slide3.xml><?xml version="1.0" encoding="utf-8"?>
+<p:sld xmlns:a="http://schemas.openxmlformats.org/drawingml/2006/main" xmlns:p="http://schemas.openxmlformats.org/presentationml/2006/main" xmlns:r="http://schemas.openxmlformats.org/officeDocument/2006/relationships">
+  <p:cSld>
+    <p:spTree>
+      <p:nvGrpSpPr>
+        <p:cNvPr id="1" name=""/>
+        <p:cNvGrpSpPr/>
+        <p:nvPr/>
+      </p:nvGrpSpPr>
+      <p:grpSpPr/>
+      <p:sp>
+        <p:nvSpPr>
+          <p:cNvPr id="2" name="Title 1"/>
+          <p:cNvSpPr>
+            <a:spLocks noGrp="1"/>
+          </p:cNvSpPr>
+          <p:nvPr>
+            <p:ph type="title"/>
+          </p:nvPr>
+        </p:nvSpPr>
+        <p:spPr/>
+        <p:txBody>
+          <a:bodyPr/>
+          <a:lstStyle/>
+          <a:p>
+            <a:pPr/>
             <a:r>
-              <a:t>Subtitle</a:t>
+              <a:t>Example Title Slide - Center</a:t>
+            </a:r>
+          </a:p>
+        </p:txBody>
+      </p:sp>
+    </p:spTree>
+  </p:cSld>
+  <p:clrMapOvr>
+    <a:masterClrMapping/>
+  </p:clrMapOvr>
+</p:sld>
+</file>
+
+<file path=ppt/slides/slide4.xml><?xml version="1.0" encoding="utf-8"?>
+<p:sld xmlns:a="http://schemas.openxmlformats.org/drawingml/2006/main" xmlns:p="http://schemas.openxmlformats.org/presentationml/2006/main" xmlns:r="http://schemas.openxmlformats.org/officeDocument/2006/relationships">
+  <p:cSld>
+    <p:spTree>
+      <p:nvGrpSpPr>
+        <p:cNvPr id="1" name=""/>
+        <p:cNvGrpSpPr/>
+        <p:nvPr/>
+      </p:nvGrpSpPr>
+      <p:grpSpPr/>
+      <p:sp>
+        <p:nvSpPr>
+          <p:cNvPr id="2" name="Title 1"/>
+          <p:cNvSpPr>
+            <a:spLocks noGrp="1"/>
+          </p:cNvSpPr>
+          <p:nvPr>
+            <p:ph type="title"/>
+          </p:nvPr>
+        </p:nvSpPr>
+        <p:spPr/>
+        <p:txBody>
+          <a:bodyPr/>
+          <a:lstStyle/>
+          <a:p>
+            <a:pPr/>
+            <a:r>
+              <a:t>Example Title</a:t>
+            </a:r>
+          </a:p>
+        </p:txBody>
+      </p:sp>
+      <p:sp>
+        <p:nvSpPr>
+          <p:cNvPr id="3" name="Text Placeholder 2"/>
+          <p:cNvSpPr>
+            <a:spLocks noGrp="1"/>
+          </p:cNvSpPr>
+          <p:nvPr>
+            <p:ph type="body" idx="1"/>
+          </p:nvPr>
+        </p:nvSpPr>
+        <p:spPr/>
+        <p:txBody>
+          <a:bodyPr/>
+          <a:lstStyle/>
+          <a:p>
+            <a:pPr/>
+            <a:r>
+              <a:t>Example Body Level One</a:t>
+            </a:r>
+          </a:p>
+        </p:txBody>
+      </p:sp>
+    </p:spTree>
+  </p:cSld>
+  <p:clrMapOvr>
+    <a:masterClrMapping/>
+  </p:clrMapOvr>
+</p:sld>
+</file>
+
+<file path=ppt/slides/slide5.xml><?xml version="1.0" encoding="utf-8"?>
+<p:sld xmlns:a="http://schemas.openxmlformats.org/drawingml/2006/main" xmlns:p="http://schemas.openxmlformats.org/presentationml/2006/main" xmlns:r="http://schemas.openxmlformats.org/officeDocument/2006/relationships">
+  <p:cSld>
+    <p:spTree>
+      <p:nvGrpSpPr>
+        <p:cNvPr id="1" name=""/>
+        <p:cNvGrpSpPr/>
+        <p:nvPr/>
+      </p:nvGrpSpPr>
+      <p:grpSpPr/>
+      <p:sp>
+        <p:nvSpPr>
+          <p:cNvPr id="2" name="Picture Placeholder 1"/>
+          <p:cNvSpPr>
+            <a:spLocks noGrp="1"/>
+          </p:cNvSpPr>
+          <p:nvPr>
+            <p:ph type="pic" idx="21" sz="half"/>
+          </p:nvPr>
+        </p:nvSpPr>
+        <p:spPr/>
+        <p:txBody>
+          <a:bodyPr/>
+          <a:p>
+            <a:pPr/>
+          </a:p>
+        </p:txBody>
+      </p:sp>
+      <p:sp>
+        <p:nvSpPr>
+          <p:cNvPr id="3" name="Title 2"/>
+          <p:cNvSpPr>
+            <a:spLocks noGrp="1"/>
+          </p:cNvSpPr>
+          <p:nvPr>
+            <p:ph type="title"/>
+          </p:nvPr>
+        </p:nvSpPr>
+        <p:spPr/>
+        <p:txBody>
+          <a:bodyPr/>
+          <a:lstStyle/>
+          <a:p/>
+        </p:txBody>
+      </p:sp>
+      <p:sp>
+        <p:nvSpPr>
+          <p:cNvPr id="4" name="Text Placeholder 3"/>
+          <p:cNvSpPr>
+            <a:spLocks noGrp="1"/>
+          </p:cNvSpPr>
+          <p:nvPr>
+            <p:ph type="body" idx="1" sz="half"/>
+          </p:nvPr>
+        </p:nvSpPr>
+        <p:spPr/>
+        <p:txBody>
+          <a:bodyPr/>
+          <a:lstStyle/>
+          <a:p/>
+        </p:txBody>
+      </p:sp>
+    </p:spTree>
+  </p:cSld>
+  <p:clrMapOvr>
+    <a:masterClrMapping/>
+  </p:clrMapOvr>
+</p:sld>
+</file>
+
+<file path=ppt/slides/slide6.xml><?xml version="1.0" encoding="utf-8"?>
+<p:sld xmlns:a="http://schemas.openxmlformats.org/drawingml/2006/main" xmlns:p="http://schemas.openxmlformats.org/presentationml/2006/main" xmlns:r="http://schemas.openxmlformats.org/officeDocument/2006/relationships">
+  <p:cSld>
+    <p:spTree>
+      <p:nvGrpSpPr>
+        <p:cNvPr id="1" name=""/>
+        <p:cNvGrpSpPr/>
+        <p:nvPr/>
+      </p:nvGrpSpPr>
+      <p:grpSpPr/>
+      <p:sp>
+        <p:nvSpPr>
+          <p:cNvPr id="2" name="Title 1"/>
+          <p:cNvSpPr>
+            <a:spLocks noGrp="1"/>
+          </p:cNvSpPr>
+          <p:nvPr>
+            <p:ph type="title"/>
+          </p:nvPr>
+        </p:nvSpPr>
+        <p:spPr/>
+        <p:txBody>
+          <a:bodyPr/>
+          <a:lstStyle/>
+          <a:p/>
+        </p:txBody>
+      </p:sp>
+      <p:sp>
+        <p:nvSpPr>
+          <p:cNvPr id="3" name="Text Placeholder 2"/>
+          <p:cNvSpPr>
+            <a:spLocks noGrp="1"/>
+          </p:cNvSpPr>
+          <p:nvPr>
+            <p:ph type="body" idx="1" sz="quarter"/>
+          </p:nvPr>
+        </p:nvSpPr>
+        <p:spPr/>
+        <p:txBody>
+          <a:bodyPr/>
+          <a:lstStyle/>
+          <a:p/>
+        </p:txBody>
+      </p:sp>
+      <p:sp>
+        <p:nvSpPr>
+          <p:cNvPr id="4" name="TextBox 3"/>
+          <p:cNvSpPr txBox="1"/>
+          <p:nvPr/>
+        </p:nvSpPr>
+        <p:spPr>
+          <a:xfrm>
+            <a:off x="4114464" y="3095576"/>
+            <a:ext cx="3963073" cy="666849"/>
+          </a:xfrm>
+          <a:prstGeom prst="rect">
+            <a:avLst/>
+          </a:prstGeom>
+          <a:noFill/>
+        </p:spPr>
+        <p:txBody>
+          <a:bodyPr wrap="none">
+            <a:spAutoFit/>
+          </a:bodyPr>
+          <a:lstStyle/>
+          <a:p>
+            <a:r>
+              <a:rPr sz="4000"/>
+              <a:t>THANK YOU</a:t>
+            </a:r>
+          </a:p>
+        </p:txBody>
+      </p:sp>
+    </p:spTree>
+  </p:cSld>
+  <p:clrMapOvr>
+    <a:masterClrMapping/>
+  </p:clrMapOvr>
+</p:sld>
+</file>
+
+<file path=ppt/slides/slide7.xml><?xml version="1.0" encoding="utf-8"?>
+<p:sld xmlns:a="http://schemas.openxmlformats.org/drawingml/2006/main" xmlns:p="http://schemas.openxmlformats.org/presentationml/2006/main" xmlns:r="http://schemas.openxmlformats.org/officeDocument/2006/relationships">
+  <p:cSld>
+    <p:spTree>
+      <p:nvGrpSpPr>
+        <p:cNvPr id="1" name=""/>
+        <p:cNvGrpSpPr/>
+        <p:nvPr/>
+      </p:nvGrpSpPr>
+      <p:grpSpPr/>
+      <p:sp>
+        <p:nvSpPr>
+          <p:cNvPr id="2" name="Title 1"/>
+          <p:cNvSpPr>
+            <a:spLocks noGrp="1"/>
+          </p:cNvSpPr>
+          <p:nvPr>
+            <p:ph type="title"/>
+          </p:nvPr>
+        </p:nvSpPr>
+        <p:spPr/>
+        <p:txBody>
+          <a:bodyPr/>
+          <a:lstStyle/>
+          <a:p/>
+        </p:txBody>
+      </p:sp>
+      <p:sp>
+        <p:nvSpPr>
+          <p:cNvPr id="3" name="Text Placeholder 2"/>
+          <p:cNvSpPr>
+            <a:spLocks noGrp="1"/>
+          </p:cNvSpPr>
+          <p:nvPr>
+            <p:ph type="body" idx="1" sz="quarter"/>
+          </p:nvPr>
+        </p:nvSpPr>
+        <p:spPr/>
+        <p:txBody>
+          <a:bodyPr/>
+          <a:lstStyle/>
+          <a:p/>
+        </p:txBody>
+      </p:sp>
+      <p:sp>
+        <p:nvSpPr>
+          <p:cNvPr id="4" name="TextBox 3"/>
+          <p:cNvSpPr txBox="1"/>
+          <p:nvPr/>
+        </p:nvSpPr>
+        <p:spPr>
+          <a:xfrm>
+            <a:off x="606361" y="3195603"/>
+            <a:ext cx="10979279" cy="466794"/>
+          </a:xfrm>
+          <a:prstGeom prst="rect">
+            <a:avLst/>
+          </a:prstGeom>
+          <a:noFill/>
+        </p:spPr>
+        <p:txBody>
+          <a:bodyPr wrap="none">
+            <a:spAutoFit/>
+          </a:bodyPr>
+          <a:lstStyle/>
+          <a:p>
+            <a:r>
+              <a:rPr sz="3000"/>
+              <a:t>Appendix</a:t>
             </a:r>
           </a:p>
         </p:txBody>

</xml_diff>